<commit_message>
Trim What We Heard slide copy and fix fact-check issues
Cards now carry one line each; headcount adds up to 21; quotes are
verbatim from the interview logs; genetics counselor card leads with
building pedigrees by hand.

Co-Authored-By: Claude Opus 5.5 <noreply@anthropic.com>
Claude-Session: https://claude.ai/code/session_01BRVHcGTPERiPJqFNwGqnWC
</commit_message>
<xml_diff>
--- a/slides/what-we-heard.pptx
+++ b/slides/what-we-heard.pptx
@@ -502,7 +502,7 @@
           <a:p>
             <a:r>
               <a:rPr lang="en-US" dirty="0"/>
-              <a:t>21 interviews: 15 patients (ID001, 003-007, 011-013, 015-020) and 6 clinicians: internal medicine physician (ID002), RN (ID008), PAs (ID009, ID014), emergency medicine doctor (ID010), genetics counselor (ID021).</a:t>
+              <a:t>21 interviews: 15 patients (ID001, 003-007, 011-013, 015-020) and 6 clinicians: internal medicine physician (ID002), RN (ID008), PAs (ID009, ID014), emergency medicine doctor (ID010), genetics counselor (D021). Genetics counselor: family history from Epic, an Ambry Care chatbot and paper questionnaires is entered by hand into Progeny, a desktop pedigree tool, one relative at a time; only ~20% of patients return the pre-visit questionnaire.</a:t>
             </a:r>
             <a:endParaRPr lang="en-US" dirty="0"/>
           </a:p>
@@ -1061,7 +1061,7 @@
                   <a:schemeClr val="tx2"/>
                 </a:solidFill>
               </a:rPr>
-              <a:t>15 patients and 6 clinicians. Families have the history, but not in a form a clinician can act on.</a:t>
+              <a:t>15 patients, 2 PAs, an ER doctor, a genetics counselor, an internist and an RN.</a:t>
             </a:r>
             <a:endParaRPr lang="en-US" sz="1400" dirty="0"/>
           </a:p>
@@ -1075,8 +1075,8 @@
         </p:nvSpPr>
         <p:spPr>
           <a:xfrm>
-            <a:off x="457200" y="1572768"/>
-            <a:ext cx="1920240" cy="2651760"/>
+            <a:off x="457200" y="1600200"/>
+            <a:ext cx="1920240" cy="2331720"/>
           </a:xfrm>
           <a:prstGeom prst="roundRect">
             <a:avLst>
@@ -1102,7 +1102,7 @@
         </p:nvSpPr>
         <p:spPr>
           <a:xfrm>
-            <a:off x="594360" y="1709928"/>
+            <a:off x="594360" y="1737360"/>
             <a:ext cx="1645920" cy="201168"/>
           </a:xfrm>
           <a:prstGeom prst="rect">
@@ -1138,8 +1138,8 @@
         </p:nvSpPr>
         <p:spPr>
           <a:xfrm>
-            <a:off x="594360" y="1938528"/>
-            <a:ext cx="1645920" cy="475488"/>
+            <a:off x="594360" y="1965960"/>
+            <a:ext cx="1645920" cy="685800"/>
           </a:xfrm>
           <a:prstGeom prst="rect">
             <a:avLst/>
@@ -1155,7 +1155,7 @@
               <a:buNone/>
             </a:pPr>
             <a:r>
-              <a:rPr lang="en-US" sz="1300" b="1" dirty="0">
+              <a:rPr lang="en-US" sz="1500" b="1" dirty="0">
                 <a:solidFill>
                   <a:schemeClr val="tx1"/>
                 </a:solidFill>
@@ -1163,9 +1163,9 @@
                 <a:ea typeface="Cambria" pitchFamily="34" charset="-122"/>
                 <a:cs typeface="Cambria" pitchFamily="34" charset="-120"/>
               </a:rPr>
-              <a:t>They know it runs in the family. Not who.</a:t>
-            </a:r>
-            <a:endParaRPr lang="en-US" sz="1300" dirty="0"/>
+              <a:t>It runs in the family. But who?</a:t>
+            </a:r>
+            <a:endParaRPr lang="en-US" sz="1500" dirty="0"/>
           </a:p>
         </p:txBody>
       </p:sp>
@@ -1177,8 +1177,8 @@
         </p:nvSpPr>
         <p:spPr>
           <a:xfrm>
-            <a:off x="594360" y="2468880"/>
-            <a:ext cx="1645920" cy="1417320"/>
+            <a:off x="594360" y="2697480"/>
+            <a:ext cx="1645920" cy="914400"/>
           </a:xfrm>
           <a:prstGeom prst="rect">
             <a:avLst/>
@@ -1197,14 +1197,14 @@
               <a:buNone/>
             </a:pPr>
             <a:r>
-              <a:rPr lang="en-US" sz="1050" dirty="0">
+              <a:rPr lang="en-US" sz="1200" dirty="0">
                 <a:solidFill>
                   <a:schemeClr val="tx2"/>
                 </a:solidFill>
               </a:rPr>
-              <a:t>One patient only learned of an uncle’s young-onset arrhythmia after calling relatives. Another said “no family history” until the GI doctor asked specifically.</a:t>
-            </a:r>
-            <a:endParaRPr lang="en-US" sz="1050" dirty="0"/>
+              <a:t>One only learned of an uncle’s young-onset arrhythmia after calling relatives.</a:t>
+            </a:r>
+            <a:endParaRPr lang="en-US" sz="1200" dirty="0"/>
           </a:p>
         </p:txBody>
       </p:sp>
@@ -1216,7 +1216,7 @@
         </p:nvSpPr>
         <p:spPr>
           <a:xfrm>
-            <a:off x="594360" y="3968496"/>
+            <a:off x="594360" y="3675888"/>
             <a:ext cx="1645920" cy="182880"/>
           </a:xfrm>
           <a:prstGeom prst="rect">
@@ -1238,7 +1238,7 @@
                   <a:schemeClr val="accent4"/>
                 </a:solidFill>
               </a:rPr>
-              <a:t>ID006 · ID007 + 13 more</a:t>
+              <a:t>ID007 + 14 more</a:t>
             </a:r>
             <a:endParaRPr lang="en-US" sz="850" dirty="0"/>
           </a:p>
@@ -1252,8 +1252,8 @@
         </p:nvSpPr>
         <p:spPr>
           <a:xfrm>
-            <a:off x="2560320" y="1572768"/>
-            <a:ext cx="1920240" cy="2651760"/>
+            <a:off x="2560320" y="1600200"/>
+            <a:ext cx="1920240" cy="2331720"/>
           </a:xfrm>
           <a:prstGeom prst="roundRect">
             <a:avLst>
@@ -1279,7 +1279,7 @@
         </p:nvSpPr>
         <p:spPr>
           <a:xfrm>
-            <a:off x="2697480" y="1709928"/>
+            <a:off x="2697480" y="1737360"/>
             <a:ext cx="1645920" cy="201168"/>
           </a:xfrm>
           <a:prstGeom prst="rect">
@@ -1315,8 +1315,8 @@
         </p:nvSpPr>
         <p:spPr>
           <a:xfrm>
-            <a:off x="2697480" y="1938528"/>
-            <a:ext cx="1645920" cy="475488"/>
+            <a:off x="2697480" y="1965960"/>
+            <a:ext cx="1645920" cy="685800"/>
           </a:xfrm>
           <a:prstGeom prst="rect">
             <a:avLst/>
@@ -1332,7 +1332,7 @@
               <a:buNone/>
             </a:pPr>
             <a:r>
-              <a:rPr lang="en-US" sz="1300" b="1" dirty="0">
+              <a:rPr lang="en-US" sz="1500" b="1" dirty="0">
                 <a:solidFill>
                   <a:schemeClr val="tx1"/>
                 </a:solidFill>
@@ -1340,9 +1340,9 @@
                 <a:ea typeface="Cambria" pitchFamily="34" charset="-122"/>
                 <a:cs typeface="Cambria" pitchFamily="34" charset="-120"/>
               </a:rPr>
-              <a:t>They rebuild the story at every follow-up.</a:t>
-            </a:r>
-            <a:endParaRPr lang="en-US" sz="1300" dirty="0"/>
+              <a:t>They rebuild the story every visit.</a:t>
+            </a:r>
+            <a:endParaRPr lang="en-US" sz="1500" dirty="0"/>
           </a:p>
         </p:txBody>
       </p:sp>
@@ -1354,8 +1354,8 @@
         </p:nvSpPr>
         <p:spPr>
           <a:xfrm>
-            <a:off x="2697480" y="2468880"/>
-            <a:ext cx="1645920" cy="1417320"/>
+            <a:off x="2697480" y="2697480"/>
+            <a:ext cx="1645920" cy="914400"/>
           </a:xfrm>
           <a:prstGeom prst="rect">
             <a:avLst/>
@@ -1374,34 +1374,14 @@
               <a:buNone/>
             </a:pPr>
             <a:r>
-              <a:rPr lang="en-US" sz="1050" dirty="0">
-                <a:solidFill>
-                  <a:schemeClr val="tx2"/>
-                </a:solidFill>
-              </a:rPr>
-              <a:t>They reconstruct what happened at the first visit and wait on outside specialists for results.</a:t>
-            </a:r>
-            <a:endParaRPr lang="en-US" sz="1050" dirty="0"/>
-          </a:p>
-          <a:p>
-            <a:pPr indent="0" marL="0">
-              <a:lnSpc>
-                <a:spcPct val="95000"/>
-              </a:lnSpc>
-              <a:spcBef>
-                <a:spcPts val="500"/>
-              </a:spcBef>
-              <a:buNone/>
-            </a:pPr>
-            <a:r>
-              <a:rPr lang="en-US" sz="1050" i="1" dirty="0">
+              <a:rPr lang="en-US" sz="1200" i="1" dirty="0">
                 <a:solidFill>
                   <a:schemeClr val="tx1"/>
                 </a:solidFill>
               </a:rPr>
               <a:t>“A result can be technically available but still not be useful until someone puts it into context.”</a:t>
             </a:r>
-            <a:endParaRPr lang="en-US" sz="1050" dirty="0"/>
+            <a:endParaRPr lang="en-US" sz="1200" dirty="0"/>
           </a:p>
         </p:txBody>
       </p:sp>
@@ -1413,7 +1393,7 @@
         </p:nvSpPr>
         <p:spPr>
           <a:xfrm>
-            <a:off x="2697480" y="3968496"/>
+            <a:off x="2697480" y="3675888"/>
             <a:ext cx="1645920" cy="182880"/>
           </a:xfrm>
           <a:prstGeom prst="rect">
@@ -1449,8 +1429,8 @@
         </p:nvSpPr>
         <p:spPr>
           <a:xfrm>
-            <a:off x="4663440" y="1572768"/>
-            <a:ext cx="1920240" cy="2651760"/>
+            <a:off x="4663440" y="1600200"/>
+            <a:ext cx="1920240" cy="2331720"/>
           </a:xfrm>
           <a:prstGeom prst="roundRect">
             <a:avLst>
@@ -1476,7 +1456,7 @@
         </p:nvSpPr>
         <p:spPr>
           <a:xfrm>
-            <a:off x="4800600" y="1709928"/>
+            <a:off x="4800600" y="1737360"/>
             <a:ext cx="1645920" cy="201168"/>
           </a:xfrm>
           <a:prstGeom prst="rect">
@@ -1512,8 +1492,8 @@
         </p:nvSpPr>
         <p:spPr>
           <a:xfrm>
-            <a:off x="4800600" y="1938528"/>
-            <a:ext cx="1645920" cy="475488"/>
+            <a:off x="4800600" y="1965960"/>
+            <a:ext cx="1645920" cy="685800"/>
           </a:xfrm>
           <a:prstGeom prst="rect">
             <a:avLst/>
@@ -1529,7 +1509,7 @@
               <a:buNone/>
             </a:pPr>
             <a:r>
-              <a:rPr lang="en-US" sz="1300" b="1" dirty="0">
+              <a:rPr lang="en-US" sz="1500" b="1" dirty="0">
                 <a:solidFill>
                   <a:schemeClr val="tx1"/>
                 </a:solidFill>
@@ -1537,9 +1517,9 @@
                 <a:ea typeface="Cambria" pitchFamily="34" charset="-122"/>
                 <a:cs typeface="Cambria" pitchFamily="34" charset="-120"/>
               </a:rPr>
-              <a:t>Only a few red flags matter, and fast.</a:t>
-            </a:r>
-            <a:endParaRPr lang="en-US" sz="1300" dirty="0"/>
+              <a:t>Only a few red flags matter.</a:t>
+            </a:r>
+            <a:endParaRPr lang="en-US" sz="1500" dirty="0"/>
           </a:p>
         </p:txBody>
       </p:sp>
@@ -1551,8 +1531,8 @@
         </p:nvSpPr>
         <p:spPr>
           <a:xfrm>
-            <a:off x="4800600" y="2468880"/>
-            <a:ext cx="1645920" cy="1417320"/>
+            <a:off x="4800600" y="2697480"/>
+            <a:ext cx="1645920" cy="914400"/>
           </a:xfrm>
           <a:prstGeom prst="rect">
             <a:avLst/>
@@ -1571,14 +1551,14 @@
               <a:buNone/>
             </a:pPr>
             <a:r>
-              <a:rPr lang="en-US" sz="1050" dirty="0">
+              <a:rPr lang="en-US" sz="1200" dirty="0">
                 <a:solidFill>
                   <a:schemeClr val="tx2"/>
                 </a:solidFill>
               </a:rPr>
-              <a:t>Chest pain, fainting, a young relative’s sudden death. No time for a full chart; a flagged, scannable summary would get used. Bigger value in primary care.</a:t>
-            </a:r>
-            <a:endParaRPr lang="en-US" sz="1050" dirty="0"/>
+              <a:t>Chest pain, fainting, a young relative’s sudden death. A flagged summary is more realistic than a full chart.</a:t>
+            </a:r>
+            <a:endParaRPr lang="en-US" sz="1200" dirty="0"/>
           </a:p>
         </p:txBody>
       </p:sp>
@@ -1590,7 +1570,7 @@
         </p:nvSpPr>
         <p:spPr>
           <a:xfrm>
-            <a:off x="4800600" y="3968496"/>
+            <a:off x="4800600" y="3675888"/>
             <a:ext cx="1645920" cy="182880"/>
           </a:xfrm>
           <a:prstGeom prst="rect">
@@ -1626,8 +1606,8 @@
         </p:nvSpPr>
         <p:spPr>
           <a:xfrm>
-            <a:off x="6766560" y="1572768"/>
-            <a:ext cx="1920240" cy="2651760"/>
+            <a:off x="6766560" y="1600200"/>
+            <a:ext cx="1920240" cy="2331720"/>
           </a:xfrm>
           <a:prstGeom prst="roundRect">
             <a:avLst>
@@ -1653,7 +1633,7 @@
         </p:nvSpPr>
         <p:spPr>
           <a:xfrm>
-            <a:off x="6903720" y="1709928"/>
+            <a:off x="6903720" y="1737360"/>
             <a:ext cx="1645920" cy="201168"/>
           </a:xfrm>
           <a:prstGeom prst="rect">
@@ -1689,8 +1669,8 @@
         </p:nvSpPr>
         <p:spPr>
           <a:xfrm>
-            <a:off x="6903720" y="1938528"/>
-            <a:ext cx="1645920" cy="475488"/>
+            <a:off x="6903720" y="1965960"/>
+            <a:ext cx="1645920" cy="685800"/>
           </a:xfrm>
           <a:prstGeom prst="rect">
             <a:avLst/>
@@ -1706,7 +1686,7 @@
               <a:buNone/>
             </a:pPr>
             <a:r>
-              <a:rPr lang="en-US" sz="1300" b="1" dirty="0">
+              <a:rPr lang="en-US" sz="1500" b="1" dirty="0">
                 <a:solidFill>
                   <a:schemeClr val="tx1"/>
                 </a:solidFill>
@@ -1714,9 +1694,9 @@
                 <a:ea typeface="Cambria" pitchFamily="34" charset="-122"/>
                 <a:cs typeface="Cambria" pitchFamily="34" charset="-120"/>
               </a:rPr>
-              <a:t>Family history is retyped by hand.</a:t>
-            </a:r>
-            <a:endParaRPr lang="en-US" sz="1300" dirty="0"/>
+              <a:t>Builds every pedigree by hand.</a:t>
+            </a:r>
+            <a:endParaRPr lang="en-US" sz="1500" dirty="0"/>
           </a:p>
         </p:txBody>
       </p:sp>
@@ -1728,8 +1708,8 @@
         </p:nvSpPr>
         <p:spPr>
           <a:xfrm>
-            <a:off x="6903720" y="2468880"/>
-            <a:ext cx="1645920" cy="1417320"/>
+            <a:off x="6903720" y="2697480"/>
+            <a:ext cx="1645920" cy="914400"/>
           </a:xfrm>
           <a:prstGeom prst="rect">
             <a:avLst/>
@@ -1748,34 +1728,14 @@
               <a:buNone/>
             </a:pPr>
             <a:r>
-              <a:rPr lang="en-US" sz="1050" dirty="0">
+              <a:rPr lang="en-US" sz="1200" dirty="0">
                 <a:solidFill>
                   <a:schemeClr val="tx2"/>
                 </a:solidFill>
               </a:rPr>
-              <a:t>Epic, a chatbot and paper forms are typed into Progeny one relative at a time; ~20% answer the questionnaire. Patients put relatives on the wrong side, so guide them.</a:t>
-            </a:r>
-            <a:endParaRPr lang="en-US" sz="1050" dirty="0"/>
-          </a:p>
-          <a:p>
-            <a:pPr indent="0" marL="0">
-              <a:lnSpc>
-                <a:spcPct val="95000"/>
-              </a:lnSpc>
-              <a:spcBef>
-                <a:spcPts val="500"/>
-              </a:spcBef>
-              <a:buNone/>
-            </a:pPr>
-            <a:r>
-              <a:rPr lang="en-US" sz="1050" i="1" dirty="0">
-                <a:solidFill>
-                  <a:schemeClr val="tx1"/>
-                </a:solidFill>
-              </a:rPr>
-              <a:t>“There has to be a human in the loop.”</a:t>
-            </a:r>
-            <a:endParaRPr lang="en-US" sz="1050" dirty="0"/>
+              <a:t>Retypes each relative from Epic, chatbots and paper into Progeny, one at a time.</a:t>
+            </a:r>
+            <a:endParaRPr lang="en-US" sz="1200" dirty="0"/>
           </a:p>
         </p:txBody>
       </p:sp>
@@ -1787,7 +1747,7 @@
         </p:nvSpPr>
         <p:spPr>
           <a:xfrm>
-            <a:off x="6903720" y="3968496"/>
+            <a:off x="6903720" y="3675888"/>
             <a:ext cx="1645920" cy="182880"/>
           </a:xfrm>
           <a:prstGeom prst="rect">
@@ -1809,7 +1769,7 @@
                   <a:schemeClr val="accent4"/>
                 </a:solidFill>
               </a:rPr>
-              <a:t>ID021</a:t>
+              <a:t>D021</a:t>
             </a:r>
             <a:endParaRPr lang="en-US" sz="850" dirty="0"/>
           </a:p>
@@ -1823,7 +1783,7 @@
         </p:nvSpPr>
         <p:spPr>
           <a:xfrm>
-            <a:off x="457200" y="4389120"/>
+            <a:off x="457200" y="4251960"/>
             <a:ext cx="8229600" cy="274320"/>
           </a:xfrm>
           <a:prstGeom prst="rect">
@@ -1840,7 +1800,7 @@
               <a:buNone/>
             </a:pPr>
             <a:r>
-              <a:rPr lang="en-US" sz="1250" b="1" dirty="0">
+              <a:rPr lang="en-US" sz="1400" b="1" dirty="0">
                 <a:solidFill>
                   <a:schemeClr val="accent1"/>
                 </a:solidFill>
@@ -1851,7 +1811,7 @@
               <a:buNone/>
             </a:pPr>
             <a:r>
-              <a:rPr lang="en-US" sz="1250" b="1" dirty="0">
+              <a:rPr lang="en-US" sz="1400" b="1" dirty="0">
                 <a:solidFill>
                   <a:schemeClr val="tx1"/>
                 </a:solidFill>
@@ -1862,14 +1822,14 @@
               <a:buNone/>
             </a:pPr>
             <a:r>
-              <a:rPr lang="en-US" sz="1250" dirty="0">
+              <a:rPr lang="en-US" sz="1400" dirty="0">
                 <a:solidFill>
                   <a:schemeClr val="tx2"/>
                 </a:solidFill>
               </a:rPr>
-              <a:t>guided questions · keep who said what, and how sure · a one-page summary a clinician can scan</a:t>
-            </a:r>
-            <a:endParaRPr lang="en-US" sz="1250" dirty="0"/>
+              <a:t>guided questions · keep who said what · a one-page summary</a:t>
+            </a:r>
+            <a:endParaRPr lang="en-US" sz="1400" dirty="0"/>
           </a:p>
         </p:txBody>
       </p:sp>

</xml_diff>

<commit_message>
Simplify What We Heard slide to a stat and four headlines
Shows 30 interviews per the team; detail moved to speaker notes.

Co-Authored-By: Claude Opus 5.5 <noreply@anthropic.com>
Claude-Session: https://claude.ai/code/session_01BRVHcGTPERiPJqFNwGqnWC
</commit_message>
<xml_diff>
--- a/slides/what-we-heard.pptx
+++ b/slides/what-we-heard.pptx
@@ -502,7 +502,12 @@
           <a:p>
             <a:r>
               <a:rPr lang="en-US" dirty="0"/>
-              <a:t>21 interviews: 15 patients (ID001, 003-007, 011-013, 015-020) and 6 clinicians: internal medicine physician (ID002), RN (ID008), PAs (ID009, ID014), emergency medicine doctor (ID010), genetics counselor (D021). Genetics counselor: family history from Epic, an Ambry Care chatbot and paper questionnaires is entered by hand into Progeny, a desktop pedigree tool, one relative at a time; only ~20% of patients return the pre-visit questionnaire.</a:t>
+              <a:t>30 interviews with patients and clinicians. Logged in Team Hub so far: 15 patients, 2 PAs, an ER doctor, a genetics counselor, an internist and an RN.
+PATIENTS: They know heart problems run in the family, not who, what, or at what age. ID007 only learned an uncle had a young-onset arrhythmia after the cardiologist sent them to ask relatives. ID006 said no family history until the GI doctor asked specifically; they would have answered differently if asked: “Has anyone in your family had long-term stomach problems or autoimmune disease?”
+PHYSICIAN ASSISTANTS (ID009, ID014): They reconstruct what happened at the first visit before deciding the next step, and wait on outside specialists to send results back. ID009: “A result can be technically available but still not be useful until someone puts it into context.”
+ER DOCTOR (ID010): Family history only matters for a few red flags: chest pain, fainting, sudden unexplained death in a young first-degree relative. A full chart review is unlikely in the ED; a flagged, scannable summary is more realistic. Bigger value in primary care.
+GENETICS COUNSELOR (D021): Family history comes from Epic, an Ambry Care chatbot and paper questionnaires, and she enters it by hand into Progeny, a desktop pedigree tool, one relative at a time. Only ~20% of patients return the pre-visit questionnaire. She expects patients building their own tree would put relatives on the wrong side, so the tool has to guide them. “There has to be a human in the loop to make the judgment about what matters.”
+What it changed: guided questions, keep who said what, a one-page summary.</a:t>
             </a:r>
             <a:endParaRPr lang="en-US" dirty="0"/>
           </a:p>
@@ -1022,14 +1027,14 @@
       </p:sp>
       <p:sp>
         <p:nvSpPr>
-          <p:cNvPr id="3" name="Subtitle"/>
+          <p:cNvPr id="3" name="Stat number"/>
           <p:cNvSpPr txBox="1"/>
           <p:nvPr/>
         </p:nvSpPr>
         <p:spPr>
           <a:xfrm>
-            <a:off x="457200" y="1097280"/>
-            <a:ext cx="8229600" cy="365760"/>
+            <a:off x="457200" y="1783080"/>
+            <a:ext cx="2011680" cy="914400"/>
           </a:xfrm>
           <a:prstGeom prst="rect">
             <a:avLst/>
@@ -1038,20 +1043,84 @@
           <a:ln/>
         </p:spPr>
         <p:txBody>
-          <a:bodyPr wrap="square" lIns="0" tIns="0" rIns="0" bIns="0" rtlCol="0" anchor="ctr"/>
+          <a:bodyPr wrap="square" lIns="0" tIns="0" rIns="0" bIns="0" rtlCol="0" anchor="b"/>
           <a:lstStyle/>
           <a:p>
             <a:pPr indent="0" marL="0">
               <a:buNone/>
             </a:pPr>
             <a:r>
-              <a:rPr lang="en-US" sz="1400" b="1" dirty="0">
+              <a:rPr lang="en-US" sz="7200" b="1" dirty="0">
+                <a:solidFill>
+                  <a:schemeClr val="accent1"/>
+                </a:solidFill>
+                <a:latin typeface="Cambria" pitchFamily="34" charset="0"/>
+                <a:ea typeface="Cambria" pitchFamily="34" charset="-122"/>
+                <a:cs typeface="Cambria" pitchFamily="34" charset="-120"/>
+              </a:rPr>
+              <a:t>30</a:t>
+            </a:r>
+            <a:endParaRPr lang="en-US" sz="7200" dirty="0"/>
+          </a:p>
+        </p:txBody>
+      </p:sp>
+      <p:sp>
+        <p:nvSpPr>
+          <p:cNvPr id="4" name="Stat label"/>
+          <p:cNvSpPr txBox="1"/>
+          <p:nvPr/>
+        </p:nvSpPr>
+        <p:spPr>
+          <a:xfrm>
+            <a:off x="457200" y="2743200"/>
+            <a:ext cx="2011680" cy="320040"/>
+          </a:xfrm>
+          <a:prstGeom prst="rect">
+            <a:avLst/>
+          </a:prstGeom>
+          <a:noFill/>
+          <a:ln/>
+        </p:spPr>
+        <p:txBody>
+          <a:bodyPr wrap="square" lIns="0" tIns="0" rIns="0" bIns="0" rtlCol="0" anchor="ctr"/>
+          <a:lstStyle/>
+          <a:p>
+            <a:pPr indent="0" marL="0">
+              <a:buNone/>
+            </a:pPr>
+            <a:r>
+              <a:rPr lang="en-US" sz="1800" b="1" dirty="0">
                 <a:solidFill>
                   <a:schemeClr val="tx1"/>
                 </a:solidFill>
               </a:rPr>
-              <a:t>21 interviews: </a:t>
-            </a:r>
+              <a:t>interviews</a:t>
+            </a:r>
+            <a:endParaRPr lang="en-US" sz="1800" dirty="0"/>
+          </a:p>
+        </p:txBody>
+      </p:sp>
+      <p:sp>
+        <p:nvSpPr>
+          <p:cNvPr id="5" name="Stat breakdown"/>
+          <p:cNvSpPr txBox="1"/>
+          <p:nvPr/>
+        </p:nvSpPr>
+        <p:spPr>
+          <a:xfrm>
+            <a:off x="457200" y="3063240"/>
+            <a:ext cx="2103120" cy="548640"/>
+          </a:xfrm>
+          <a:prstGeom prst="rect">
+            <a:avLst/>
+          </a:prstGeom>
+          <a:noFill/>
+          <a:ln/>
+        </p:spPr>
+        <p:txBody>
+          <a:bodyPr wrap="square" lIns="0" tIns="0" rIns="0" bIns="0" rtlCol="0" anchor="t"/>
+          <a:lstStyle/>
+          <a:p>
             <a:pPr indent="0" marL="0">
               <a:buNone/>
             </a:pPr>
@@ -1061,7 +1130,7 @@
                   <a:schemeClr val="tx2"/>
                 </a:solidFill>
               </a:rPr>
-              <a:t>15 patients, 2 PAs, an ER doctor, a genetics counselor, an internist and an RN.</a:t>
+              <a:t>with patients and clinicians</a:t>
             </a:r>
             <a:endParaRPr lang="en-US" sz="1400" dirty="0"/>
           </a:p>
@@ -1069,18 +1138,18 @@
       </p:sp>
       <p:sp>
         <p:nvSpPr>
-          <p:cNvPr id="4" name="Card 1"/>
+          <p:cNvPr id="6" name="Card 1"/>
           <p:cNvSpPr/>
           <p:nvPr/>
         </p:nvSpPr>
         <p:spPr>
           <a:xfrm>
-            <a:off x="457200" y="1600200"/>
-            <a:ext cx="1920240" cy="2331720"/>
+            <a:off x="2743200" y="1371600"/>
+            <a:ext cx="2880360" cy="1325880"/>
           </a:xfrm>
           <a:prstGeom prst="roundRect">
             <a:avLst>
-              <a:gd name="adj" fmla="val 3810"/>
+              <a:gd name="adj" fmla="val 5517"/>
             </a:avLst>
           </a:prstGeom>
           <a:solidFill>
@@ -1096,14 +1165,14 @@
       </p:sp>
       <p:sp>
         <p:nvSpPr>
-          <p:cNvPr id="5" name="Card 1 label"/>
+          <p:cNvPr id="7" name="Card 1 label"/>
           <p:cNvSpPr txBox="1"/>
           <p:nvPr/>
         </p:nvSpPr>
         <p:spPr>
           <a:xfrm>
-            <a:off x="594360" y="1737360"/>
-            <a:ext cx="1645920" cy="201168"/>
+            <a:off x="2944368" y="1554480"/>
+            <a:ext cx="2478024" cy="228600"/>
           </a:xfrm>
           <a:prstGeom prst="rect">
             <a:avLst/>
@@ -1119,27 +1188,27 @@
               <a:buNone/>
             </a:pPr>
             <a:r>
-              <a:rPr lang="en-US" sz="900" b="1" spc="100" kern="0" dirty="0">
+              <a:rPr lang="en-US" sz="1000" b="1" spc="100" kern="0" dirty="0">
                 <a:solidFill>
                   <a:schemeClr val="accent1"/>
                 </a:solidFill>
               </a:rPr>
-              <a:t>15 PATIENTS</a:t>
-            </a:r>
-            <a:endParaRPr lang="en-US" sz="900" dirty="0"/>
-          </a:p>
-        </p:txBody>
-      </p:sp>
-      <p:sp>
-        <p:nvSpPr>
-          <p:cNvPr id="6" name="Card 1 heading"/>
+              <a:t>PATIENTS</a:t>
+            </a:r>
+            <a:endParaRPr lang="en-US" sz="1000" dirty="0"/>
+          </a:p>
+        </p:txBody>
+      </p:sp>
+      <p:sp>
+        <p:nvSpPr>
+          <p:cNvPr id="8" name="Card 1 heading"/>
           <p:cNvSpPr txBox="1"/>
           <p:nvPr/>
         </p:nvSpPr>
         <p:spPr>
           <a:xfrm>
-            <a:off x="594360" y="1965960"/>
-            <a:ext cx="1645920" cy="685800"/>
+            <a:off x="2944368" y="1828800"/>
+            <a:ext cx="2478024" cy="731520"/>
           </a:xfrm>
           <a:prstGeom prst="rect">
             <a:avLst/>
@@ -1155,7 +1224,7 @@
               <a:buNone/>
             </a:pPr>
             <a:r>
-              <a:rPr lang="en-US" sz="1500" b="1" dirty="0">
+              <a:rPr lang="en-US" sz="1800" b="1" dirty="0">
                 <a:solidFill>
                   <a:schemeClr val="tx1"/>
                 </a:solidFill>
@@ -1163,84 +1232,9 @@
                 <a:ea typeface="Cambria" pitchFamily="34" charset="-122"/>
                 <a:cs typeface="Cambria" pitchFamily="34" charset="-120"/>
               </a:rPr>
-              <a:t>It runs in the family. But who?</a:t>
-            </a:r>
-            <a:endParaRPr lang="en-US" sz="1500" dirty="0"/>
-          </a:p>
-        </p:txBody>
-      </p:sp>
-      <p:sp>
-        <p:nvSpPr>
-          <p:cNvPr id="7" name="Card 1 body"/>
-          <p:cNvSpPr txBox="1"/>
-          <p:nvPr/>
-        </p:nvSpPr>
-        <p:spPr>
-          <a:xfrm>
-            <a:off x="594360" y="2697480"/>
-            <a:ext cx="1645920" cy="914400"/>
-          </a:xfrm>
-          <a:prstGeom prst="rect">
-            <a:avLst/>
-          </a:prstGeom>
-          <a:noFill/>
-          <a:ln/>
-        </p:spPr>
-        <p:txBody>
-          <a:bodyPr wrap="square" lIns="0" tIns="0" rIns="0" bIns="0" rtlCol="0" anchor="t"/>
-          <a:lstStyle/>
-          <a:p>
-            <a:pPr indent="0" marL="0">
-              <a:lnSpc>
-                <a:spcPct val="95000"/>
-              </a:lnSpc>
-              <a:buNone/>
-            </a:pPr>
-            <a:r>
-              <a:rPr lang="en-US" sz="1200" dirty="0">
-                <a:solidFill>
-                  <a:schemeClr val="tx2"/>
-                </a:solidFill>
-              </a:rPr>
-              <a:t>One only learned of an uncle’s young-onset arrhythmia after calling relatives.</a:t>
-            </a:r>
-            <a:endParaRPr lang="en-US" sz="1200" dirty="0"/>
-          </a:p>
-        </p:txBody>
-      </p:sp>
-      <p:sp>
-        <p:nvSpPr>
-          <p:cNvPr id="8" name="Card 1 source"/>
-          <p:cNvSpPr txBox="1"/>
-          <p:nvPr/>
-        </p:nvSpPr>
-        <p:spPr>
-          <a:xfrm>
-            <a:off x="594360" y="3675888"/>
-            <a:ext cx="1645920" cy="182880"/>
-          </a:xfrm>
-          <a:prstGeom prst="rect">
-            <a:avLst/>
-          </a:prstGeom>
-          <a:noFill/>
-          <a:ln/>
-        </p:spPr>
-        <p:txBody>
-          <a:bodyPr wrap="square" lIns="0" tIns="0" rIns="0" bIns="0" rtlCol="0" anchor="ctr"/>
-          <a:lstStyle/>
-          <a:p>
-            <a:pPr indent="0" marL="0">
-              <a:buNone/>
-            </a:pPr>
-            <a:r>
-              <a:rPr lang="en-US" sz="850" dirty="0">
-                <a:solidFill>
-                  <a:schemeClr val="accent4"/>
-                </a:solidFill>
-              </a:rPr>
-              <a:t>ID007 + 14 more</a:t>
-            </a:r>
-            <a:endParaRPr lang="en-US" sz="850" dirty="0"/>
+              <a:t>“It runs in the family.” But who?</a:t>
+            </a:r>
+            <a:endParaRPr lang="en-US" sz="1800" dirty="0"/>
           </a:p>
         </p:txBody>
       </p:sp>
@@ -1252,12 +1246,12 @@
         </p:nvSpPr>
         <p:spPr>
           <a:xfrm>
-            <a:off x="2560320" y="1600200"/>
-            <a:ext cx="1920240" cy="2331720"/>
+            <a:off x="5806440" y="1371600"/>
+            <a:ext cx="2880360" cy="1325880"/>
           </a:xfrm>
           <a:prstGeom prst="roundRect">
             <a:avLst>
-              <a:gd name="adj" fmla="val 3810"/>
+              <a:gd name="adj" fmla="val 5517"/>
             </a:avLst>
           </a:prstGeom>
           <a:solidFill>
@@ -1279,8 +1273,8 @@
         </p:nvSpPr>
         <p:spPr>
           <a:xfrm>
-            <a:off x="2697480" y="1737360"/>
-            <a:ext cx="1645920" cy="201168"/>
+            <a:off x="6007608" y="1554480"/>
+            <a:ext cx="2478024" cy="228600"/>
           </a:xfrm>
           <a:prstGeom prst="rect">
             <a:avLst/>
@@ -1296,14 +1290,14 @@
               <a:buNone/>
             </a:pPr>
             <a:r>
-              <a:rPr lang="en-US" sz="900" b="1" spc="100" kern="0" dirty="0">
+              <a:rPr lang="en-US" sz="1000" b="1" spc="100" kern="0" dirty="0">
                 <a:solidFill>
                   <a:schemeClr val="accent1"/>
                 </a:solidFill>
               </a:rPr>
-              <a:t>2 PHYSICIAN ASSISTANTS</a:t>
-            </a:r>
-            <a:endParaRPr lang="en-US" sz="900" dirty="0"/>
+              <a:t>PHYSICIAN ASSISTANTS</a:t>
+            </a:r>
+            <a:endParaRPr lang="en-US" sz="1000" dirty="0"/>
           </a:p>
         </p:txBody>
       </p:sp>
@@ -1315,8 +1309,8 @@
         </p:nvSpPr>
         <p:spPr>
           <a:xfrm>
-            <a:off x="2697480" y="1965960"/>
-            <a:ext cx="1645920" cy="685800"/>
+            <a:off x="6007608" y="1828800"/>
+            <a:ext cx="2478024" cy="731520"/>
           </a:xfrm>
           <a:prstGeom prst="rect">
             <a:avLst/>
@@ -1332,7 +1326,7 @@
               <a:buNone/>
             </a:pPr>
             <a:r>
-              <a:rPr lang="en-US" sz="1500" b="1" dirty="0">
+              <a:rPr lang="en-US" sz="1800" b="1" dirty="0">
                 <a:solidFill>
                   <a:schemeClr val="tx1"/>
                 </a:solidFill>
@@ -1340,176 +1334,16 @@
                 <a:ea typeface="Cambria" pitchFamily="34" charset="-122"/>
                 <a:cs typeface="Cambria" pitchFamily="34" charset="-120"/>
               </a:rPr>
-              <a:t>They rebuild the story every visit.</a:t>
-            </a:r>
-            <a:endParaRPr lang="en-US" sz="1500" dirty="0"/>
-          </a:p>
-        </p:txBody>
-      </p:sp>
-      <p:sp>
-        <p:nvSpPr>
-          <p:cNvPr id="12" name="Card 2 body"/>
-          <p:cNvSpPr txBox="1"/>
-          <p:nvPr/>
-        </p:nvSpPr>
-        <p:spPr>
-          <a:xfrm>
-            <a:off x="2697480" y="2697480"/>
-            <a:ext cx="1645920" cy="914400"/>
-          </a:xfrm>
-          <a:prstGeom prst="rect">
-            <a:avLst/>
-          </a:prstGeom>
-          <a:noFill/>
-          <a:ln/>
-        </p:spPr>
-        <p:txBody>
-          <a:bodyPr wrap="square" lIns="0" tIns="0" rIns="0" bIns="0" rtlCol="0" anchor="t"/>
-          <a:lstStyle/>
-          <a:p>
-            <a:pPr indent="0" marL="0">
-              <a:lnSpc>
-                <a:spcPct val="95000"/>
-              </a:lnSpc>
-              <a:buNone/>
-            </a:pPr>
-            <a:r>
-              <a:rPr lang="en-US" sz="1200" i="1" dirty="0">
-                <a:solidFill>
-                  <a:schemeClr val="tx1"/>
-                </a:solidFill>
-              </a:rPr>
-              <a:t>“A result can be technically available but still not be useful until someone puts it into context.”</a:t>
-            </a:r>
-            <a:endParaRPr lang="en-US" sz="1200" dirty="0"/>
-          </a:p>
-        </p:txBody>
-      </p:sp>
-      <p:sp>
-        <p:nvSpPr>
-          <p:cNvPr id="13" name="Card 2 source"/>
-          <p:cNvSpPr txBox="1"/>
-          <p:nvPr/>
-        </p:nvSpPr>
-        <p:spPr>
-          <a:xfrm>
-            <a:off x="2697480" y="3675888"/>
-            <a:ext cx="1645920" cy="182880"/>
-          </a:xfrm>
-          <a:prstGeom prst="rect">
-            <a:avLst/>
-          </a:prstGeom>
-          <a:noFill/>
-          <a:ln/>
-        </p:spPr>
-        <p:txBody>
-          <a:bodyPr wrap="square" lIns="0" tIns="0" rIns="0" bIns="0" rtlCol="0" anchor="ctr"/>
-          <a:lstStyle/>
+              <a:t>They rebuild the</a:t>
+            </a:r>
+            <a:endParaRPr lang="en-US" sz="1800" dirty="0"/>
+          </a:p>
           <a:p>
             <a:pPr indent="0" marL="0">
               <a:buNone/>
             </a:pPr>
             <a:r>
-              <a:rPr lang="en-US" sz="850" dirty="0">
-                <a:solidFill>
-                  <a:schemeClr val="accent4"/>
-                </a:solidFill>
-              </a:rPr>
-              <a:t>ID009 · ID014</a:t>
-            </a:r>
-            <a:endParaRPr lang="en-US" sz="850" dirty="0"/>
-          </a:p>
-        </p:txBody>
-      </p:sp>
-      <p:sp>
-        <p:nvSpPr>
-          <p:cNvPr id="14" name="Card 3"/>
-          <p:cNvSpPr/>
-          <p:nvPr/>
-        </p:nvSpPr>
-        <p:spPr>
-          <a:xfrm>
-            <a:off x="4663440" y="1600200"/>
-            <a:ext cx="1920240" cy="2331720"/>
-          </a:xfrm>
-          <a:prstGeom prst="roundRect">
-            <a:avLst>
-              <a:gd name="adj" fmla="val 3810"/>
-            </a:avLst>
-          </a:prstGeom>
-          <a:solidFill>
-            <a:schemeClr val="bg2"/>
-          </a:solidFill>
-          <a:ln w="12700">
-            <a:solidFill>
-              <a:schemeClr val="accent5"/>
-            </a:solidFill>
-            <a:prstDash val="solid"/>
-          </a:ln>
-        </p:spPr>
-      </p:sp>
-      <p:sp>
-        <p:nvSpPr>
-          <p:cNvPr id="15" name="Card 3 label"/>
-          <p:cNvSpPr txBox="1"/>
-          <p:nvPr/>
-        </p:nvSpPr>
-        <p:spPr>
-          <a:xfrm>
-            <a:off x="4800600" y="1737360"/>
-            <a:ext cx="1645920" cy="201168"/>
-          </a:xfrm>
-          <a:prstGeom prst="rect">
-            <a:avLst/>
-          </a:prstGeom>
-          <a:noFill/>
-          <a:ln/>
-        </p:spPr>
-        <p:txBody>
-          <a:bodyPr wrap="square" lIns="0" tIns="0" rIns="0" bIns="0" rtlCol="0" anchor="ctr"/>
-          <a:lstStyle/>
-          <a:p>
-            <a:pPr indent="0" marL="0">
-              <a:buNone/>
-            </a:pPr>
-            <a:r>
-              <a:rPr lang="en-US" sz="900" b="1" spc="100" kern="0" dirty="0">
-                <a:solidFill>
-                  <a:schemeClr val="accent1"/>
-                </a:solidFill>
-              </a:rPr>
-              <a:t>1 EMERGENCY DOCTOR</a:t>
-            </a:r>
-            <a:endParaRPr lang="en-US" sz="900" dirty="0"/>
-          </a:p>
-        </p:txBody>
-      </p:sp>
-      <p:sp>
-        <p:nvSpPr>
-          <p:cNvPr id="16" name="Card 3 heading"/>
-          <p:cNvSpPr txBox="1"/>
-          <p:nvPr/>
-        </p:nvSpPr>
-        <p:spPr>
-          <a:xfrm>
-            <a:off x="4800600" y="1965960"/>
-            <a:ext cx="1645920" cy="685800"/>
-          </a:xfrm>
-          <a:prstGeom prst="rect">
-            <a:avLst/>
-          </a:prstGeom>
-          <a:noFill/>
-          <a:ln/>
-        </p:spPr>
-        <p:txBody>
-          <a:bodyPr wrap="square" lIns="0" tIns="0" rIns="0" bIns="0" rtlCol="0" anchor="t"/>
-          <a:lstStyle/>
-          <a:p>
-            <a:pPr indent="0" marL="0">
-              <a:buNone/>
-            </a:pPr>
-            <a:r>
-              <a:rPr lang="en-US" sz="1500" b="1" dirty="0">
+              <a:rPr lang="en-US" sz="1800" b="1" dirty="0">
                 <a:solidFill>
                   <a:schemeClr val="tx1"/>
                 </a:solidFill>
@@ -1517,101 +1351,26 @@
                 <a:ea typeface="Cambria" pitchFamily="34" charset="-122"/>
                 <a:cs typeface="Cambria" pitchFamily="34" charset="-120"/>
               </a:rPr>
-              <a:t>Only a few red flags matter.</a:t>
-            </a:r>
-            <a:endParaRPr lang="en-US" sz="1500" dirty="0"/>
-          </a:p>
-        </p:txBody>
-      </p:sp>
-      <p:sp>
-        <p:nvSpPr>
-          <p:cNvPr id="17" name="Card 3 body"/>
-          <p:cNvSpPr txBox="1"/>
-          <p:nvPr/>
-        </p:nvSpPr>
-        <p:spPr>
-          <a:xfrm>
-            <a:off x="4800600" y="2697480"/>
-            <a:ext cx="1645920" cy="914400"/>
-          </a:xfrm>
-          <a:prstGeom prst="rect">
-            <a:avLst/>
-          </a:prstGeom>
-          <a:noFill/>
-          <a:ln/>
-        </p:spPr>
-        <p:txBody>
-          <a:bodyPr wrap="square" lIns="0" tIns="0" rIns="0" bIns="0" rtlCol="0" anchor="t"/>
-          <a:lstStyle/>
-          <a:p>
-            <a:pPr indent="0" marL="0">
-              <a:lnSpc>
-                <a:spcPct val="95000"/>
-              </a:lnSpc>
-              <a:buNone/>
-            </a:pPr>
-            <a:r>
-              <a:rPr lang="en-US" sz="1200" dirty="0">
-                <a:solidFill>
-                  <a:schemeClr val="tx2"/>
-                </a:solidFill>
-              </a:rPr>
-              <a:t>Chest pain, fainting, a young relative’s sudden death. A flagged summary is more realistic than a full chart.</a:t>
-            </a:r>
-            <a:endParaRPr lang="en-US" sz="1200" dirty="0"/>
-          </a:p>
-        </p:txBody>
-      </p:sp>
-      <p:sp>
-        <p:nvSpPr>
-          <p:cNvPr id="18" name="Card 3 source"/>
-          <p:cNvSpPr txBox="1"/>
-          <p:nvPr/>
-        </p:nvSpPr>
-        <p:spPr>
-          <a:xfrm>
-            <a:off x="4800600" y="3675888"/>
-            <a:ext cx="1645920" cy="182880"/>
-          </a:xfrm>
-          <a:prstGeom prst="rect">
-            <a:avLst/>
-          </a:prstGeom>
-          <a:noFill/>
-          <a:ln/>
-        </p:spPr>
-        <p:txBody>
-          <a:bodyPr wrap="square" lIns="0" tIns="0" rIns="0" bIns="0" rtlCol="0" anchor="ctr"/>
-          <a:lstStyle/>
-          <a:p>
-            <a:pPr indent="0" marL="0">
-              <a:buNone/>
-            </a:pPr>
-            <a:r>
-              <a:rPr lang="en-US" sz="850" dirty="0">
-                <a:solidFill>
-                  <a:schemeClr val="accent4"/>
-                </a:solidFill>
-              </a:rPr>
-              <a:t>ID010</a:t>
-            </a:r>
-            <a:endParaRPr lang="en-US" sz="850" dirty="0"/>
-          </a:p>
-        </p:txBody>
-      </p:sp>
-      <p:sp>
-        <p:nvSpPr>
-          <p:cNvPr id="19" name="Card 4"/>
+              <a:t>story every visit.</a:t>
+            </a:r>
+            <a:endParaRPr lang="en-US" sz="1800" dirty="0"/>
+          </a:p>
+        </p:txBody>
+      </p:sp>
+      <p:sp>
+        <p:nvSpPr>
+          <p:cNvPr id="12" name="Card 3"/>
           <p:cNvSpPr/>
           <p:nvPr/>
         </p:nvSpPr>
         <p:spPr>
           <a:xfrm>
-            <a:off x="6766560" y="1600200"/>
-            <a:ext cx="1920240" cy="2331720"/>
+            <a:off x="2743200" y="2880360"/>
+            <a:ext cx="2880360" cy="1325880"/>
           </a:xfrm>
           <a:prstGeom prst="roundRect">
             <a:avLst>
-              <a:gd name="adj" fmla="val 3810"/>
+              <a:gd name="adj" fmla="val 5517"/>
             </a:avLst>
           </a:prstGeom>
           <a:solidFill>
@@ -1627,14 +1386,14 @@
       </p:sp>
       <p:sp>
         <p:nvSpPr>
-          <p:cNvPr id="20" name="Card 4 label"/>
+          <p:cNvPr id="13" name="Card 3 label"/>
           <p:cNvSpPr txBox="1"/>
           <p:nvPr/>
         </p:nvSpPr>
         <p:spPr>
           <a:xfrm>
-            <a:off x="6903720" y="1737360"/>
-            <a:ext cx="1645920" cy="201168"/>
+            <a:off x="2944368" y="3063240"/>
+            <a:ext cx="2478024" cy="228600"/>
           </a:xfrm>
           <a:prstGeom prst="rect">
             <a:avLst/>
@@ -1650,27 +1409,27 @@
               <a:buNone/>
             </a:pPr>
             <a:r>
-              <a:rPr lang="en-US" sz="900" b="1" spc="100" kern="0" dirty="0">
+              <a:rPr lang="en-US" sz="1000" b="1" spc="100" kern="0" dirty="0">
                 <a:solidFill>
                   <a:schemeClr val="accent1"/>
                 </a:solidFill>
               </a:rPr>
-              <a:t>1 GENETICS COUNSELOR</a:t>
-            </a:r>
-            <a:endParaRPr lang="en-US" sz="900" dirty="0"/>
-          </a:p>
-        </p:txBody>
-      </p:sp>
-      <p:sp>
-        <p:nvSpPr>
-          <p:cNvPr id="21" name="Card 4 heading"/>
+              <a:t>ER DOCTOR</a:t>
+            </a:r>
+            <a:endParaRPr lang="en-US" sz="1000" dirty="0"/>
+          </a:p>
+        </p:txBody>
+      </p:sp>
+      <p:sp>
+        <p:nvSpPr>
+          <p:cNvPr id="14" name="Card 3 heading"/>
           <p:cNvSpPr txBox="1"/>
           <p:nvPr/>
         </p:nvSpPr>
         <p:spPr>
           <a:xfrm>
-            <a:off x="6903720" y="1965960"/>
-            <a:ext cx="1645920" cy="685800"/>
+            <a:off x="2944368" y="3337560"/>
+            <a:ext cx="2478024" cy="731520"/>
           </a:xfrm>
           <a:prstGeom prst="rect">
             <a:avLst/>
@@ -1686,7 +1445,7 @@
               <a:buNone/>
             </a:pPr>
             <a:r>
-              <a:rPr lang="en-US" sz="1500" b="1" dirty="0">
+              <a:rPr lang="en-US" sz="1800" b="1" dirty="0">
                 <a:solidFill>
                   <a:schemeClr val="tx1"/>
                 </a:solidFill>
@@ -1694,97 +1453,66 @@
                 <a:ea typeface="Cambria" pitchFamily="34" charset="-122"/>
                 <a:cs typeface="Cambria" pitchFamily="34" charset="-120"/>
               </a:rPr>
-              <a:t>Builds every pedigree by hand.</a:t>
-            </a:r>
-            <a:endParaRPr lang="en-US" sz="1500" dirty="0"/>
-          </a:p>
-        </p:txBody>
-      </p:sp>
-      <p:sp>
-        <p:nvSpPr>
-          <p:cNvPr id="22" name="Card 4 body"/>
-          <p:cNvSpPr txBox="1"/>
-          <p:nvPr/>
-        </p:nvSpPr>
-        <p:spPr>
-          <a:xfrm>
-            <a:off x="6903720" y="2697480"/>
-            <a:ext cx="1645920" cy="914400"/>
-          </a:xfrm>
-          <a:prstGeom prst="rect">
-            <a:avLst/>
-          </a:prstGeom>
-          <a:noFill/>
-          <a:ln/>
-        </p:spPr>
-        <p:txBody>
-          <a:bodyPr wrap="square" lIns="0" tIns="0" rIns="0" bIns="0" rtlCol="0" anchor="t"/>
-          <a:lstStyle/>
-          <a:p>
-            <a:pPr indent="0" marL="0">
-              <a:lnSpc>
-                <a:spcPct val="95000"/>
-              </a:lnSpc>
-              <a:buNone/>
-            </a:pPr>
-            <a:r>
-              <a:rPr lang="en-US" sz="1200" dirty="0">
-                <a:solidFill>
-                  <a:schemeClr val="tx2"/>
-                </a:solidFill>
-              </a:rPr>
-              <a:t>Retypes each relative from Epic, chatbots and paper into Progeny, one at a time.</a:t>
-            </a:r>
-            <a:endParaRPr lang="en-US" sz="1200" dirty="0"/>
-          </a:p>
-        </p:txBody>
-      </p:sp>
-      <p:sp>
-        <p:nvSpPr>
-          <p:cNvPr id="23" name="Card 4 source"/>
-          <p:cNvSpPr txBox="1"/>
-          <p:nvPr/>
-        </p:nvSpPr>
-        <p:spPr>
-          <a:xfrm>
-            <a:off x="6903720" y="3675888"/>
-            <a:ext cx="1645920" cy="182880"/>
-          </a:xfrm>
-          <a:prstGeom prst="rect">
-            <a:avLst/>
-          </a:prstGeom>
-          <a:noFill/>
-          <a:ln/>
-        </p:spPr>
-        <p:txBody>
-          <a:bodyPr wrap="square" lIns="0" tIns="0" rIns="0" bIns="0" rtlCol="0" anchor="ctr"/>
-          <a:lstStyle/>
+              <a:t>Red flags,</a:t>
+            </a:r>
+            <a:endParaRPr lang="en-US" sz="1800" dirty="0"/>
+          </a:p>
           <a:p>
             <a:pPr indent="0" marL="0">
               <a:buNone/>
             </a:pPr>
             <a:r>
-              <a:rPr lang="en-US" sz="850" dirty="0">
+              <a:rPr lang="en-US" sz="1800" b="1" dirty="0">
                 <a:solidFill>
-                  <a:schemeClr val="accent4"/>
+                  <a:schemeClr val="tx1"/>
                 </a:solidFill>
+                <a:latin typeface="Cambria" pitchFamily="34" charset="0"/>
+                <a:ea typeface="Cambria" pitchFamily="34" charset="-122"/>
+                <a:cs typeface="Cambria" pitchFamily="34" charset="-120"/>
               </a:rPr>
-              <a:t>D021</a:t>
-            </a:r>
-            <a:endParaRPr lang="en-US" sz="850" dirty="0"/>
-          </a:p>
-        </p:txBody>
-      </p:sp>
-      <p:sp>
-        <p:nvSpPr>
-          <p:cNvPr id="24" name="Takeaway"/>
+              <a:t>not a full chart.</a:t>
+            </a:r>
+            <a:endParaRPr lang="en-US" sz="1800" dirty="0"/>
+          </a:p>
+        </p:txBody>
+      </p:sp>
+      <p:sp>
+        <p:nvSpPr>
+          <p:cNvPr id="15" name="Card 4"/>
+          <p:cNvSpPr/>
+          <p:nvPr/>
+        </p:nvSpPr>
+        <p:spPr>
+          <a:xfrm>
+            <a:off x="5806440" y="2880360"/>
+            <a:ext cx="2880360" cy="1325880"/>
+          </a:xfrm>
+          <a:prstGeom prst="roundRect">
+            <a:avLst>
+              <a:gd name="adj" fmla="val 5517"/>
+            </a:avLst>
+          </a:prstGeom>
+          <a:solidFill>
+            <a:schemeClr val="bg2"/>
+          </a:solidFill>
+          <a:ln w="12700">
+            <a:solidFill>
+              <a:schemeClr val="accent5"/>
+            </a:solidFill>
+            <a:prstDash val="solid"/>
+          </a:ln>
+        </p:spPr>
+      </p:sp>
+      <p:sp>
+        <p:nvSpPr>
+          <p:cNvPr id="16" name="Card 4 label"/>
           <p:cNvSpPr txBox="1"/>
           <p:nvPr/>
         </p:nvSpPr>
         <p:spPr>
           <a:xfrm>
-            <a:off x="457200" y="4251960"/>
-            <a:ext cx="8229600" cy="274320"/>
+            <a:off x="6007608" y="3063240"/>
+            <a:ext cx="2478024" cy="228600"/>
           </a:xfrm>
           <a:prstGeom prst="rect">
             <a:avLst/>
@@ -1800,48 +1528,82 @@
               <a:buNone/>
             </a:pPr>
             <a:r>
-              <a:rPr lang="en-US" sz="1400" b="1" dirty="0">
+              <a:rPr lang="en-US" sz="1000" b="1" spc="100" kern="0" dirty="0">
                 <a:solidFill>
                   <a:schemeClr val="accent1"/>
                 </a:solidFill>
               </a:rPr>
-              <a:t>+ </a:t>
-            </a:r>
+              <a:t>GENETICS COUNSELOR</a:t>
+            </a:r>
+            <a:endParaRPr lang="en-US" sz="1000" dirty="0"/>
+          </a:p>
+        </p:txBody>
+      </p:sp>
+      <p:sp>
+        <p:nvSpPr>
+          <p:cNvPr id="17" name="Card 4 heading"/>
+          <p:cNvSpPr txBox="1"/>
+          <p:nvPr/>
+        </p:nvSpPr>
+        <p:spPr>
+          <a:xfrm>
+            <a:off x="6007608" y="3337560"/>
+            <a:ext cx="2478024" cy="731520"/>
+          </a:xfrm>
+          <a:prstGeom prst="rect">
+            <a:avLst/>
+          </a:prstGeom>
+          <a:noFill/>
+          <a:ln/>
+        </p:spPr>
+        <p:txBody>
+          <a:bodyPr wrap="square" lIns="0" tIns="0" rIns="0" bIns="0" rtlCol="0" anchor="t"/>
+          <a:lstStyle/>
+          <a:p>
             <a:pPr indent="0" marL="0">
               <a:buNone/>
             </a:pPr>
             <a:r>
-              <a:rPr lang="en-US" sz="1400" b="1" dirty="0">
+              <a:rPr lang="en-US" sz="1800" b="1" dirty="0">
                 <a:solidFill>
                   <a:schemeClr val="tx1"/>
                 </a:solidFill>
+                <a:latin typeface="Cambria" pitchFamily="34" charset="0"/>
+                <a:ea typeface="Cambria" pitchFamily="34" charset="-122"/>
+                <a:cs typeface="Cambria" pitchFamily="34" charset="-120"/>
               </a:rPr>
-              <a:t>What it changed: </a:t>
-            </a:r>
+              <a:t>Every pedigree</a:t>
+            </a:r>
+            <a:endParaRPr lang="en-US" sz="1800" dirty="0"/>
+          </a:p>
+          <a:p>
             <a:pPr indent="0" marL="0">
               <a:buNone/>
             </a:pPr>
             <a:r>
-              <a:rPr lang="en-US" sz="1400" dirty="0">
+              <a:rPr lang="en-US" sz="1800" b="1" dirty="0">
                 <a:solidFill>
-                  <a:schemeClr val="tx2"/>
+                  <a:schemeClr val="tx1"/>
                 </a:solidFill>
+                <a:latin typeface="Cambria" pitchFamily="34" charset="0"/>
+                <a:ea typeface="Cambria" pitchFamily="34" charset="-122"/>
+                <a:cs typeface="Cambria" pitchFamily="34" charset="-120"/>
               </a:rPr>
-              <a:t>guided questions · keep who said what · a one-page summary</a:t>
-            </a:r>
-            <a:endParaRPr lang="en-US" sz="1400" dirty="0"/>
-          </a:p>
-        </p:txBody>
-      </p:sp>
-      <p:sp>
-        <p:nvSpPr>
-          <p:cNvPr id="25" name="Footer"/>
+              <a:t>built by hand.</a:t>
+            </a:r>
+            <a:endParaRPr lang="en-US" sz="1800" dirty="0"/>
+          </a:p>
+        </p:txBody>
+      </p:sp>
+      <p:sp>
+        <p:nvSpPr>
+          <p:cNvPr id="18" name="Footer"/>
           <p:cNvSpPr txBox="1"/>
           <p:nvPr/>
         </p:nvSpPr>
         <p:spPr>
           <a:xfrm>
-            <a:off x="6400800" y="4800600"/>
+            <a:off x="6400800" y="4773168"/>
             <a:ext cx="2286000" cy="201168"/>
           </a:xfrm>
           <a:prstGeom prst="rect">
@@ -1863,43 +1625,7 @@
                   <a:srgbClr val="9CA3AF"/>
                 </a:solidFill>
               </a:rPr>
-              <a:t>Research · 21 interviews</a:t>
-            </a:r>
-            <a:endParaRPr lang="en-US" sz="900" dirty="0"/>
-          </a:p>
-        </p:txBody>
-      </p:sp>
-      <p:sp>
-        <p:nvSpPr>
-          <p:cNvPr id="26" name="Source note"/>
-          <p:cNvSpPr txBox="1"/>
-          <p:nvPr/>
-        </p:nvSpPr>
-        <p:spPr>
-          <a:xfrm>
-            <a:off x="457200" y="4800600"/>
-            <a:ext cx="3657600" cy="201168"/>
-          </a:xfrm>
-          <a:prstGeom prst="rect">
-            <a:avLst/>
-          </a:prstGeom>
-          <a:noFill/>
-          <a:ln/>
-        </p:spPr>
-        <p:txBody>
-          <a:bodyPr wrap="square" lIns="0" tIns="0" rIns="0" bIns="0" rtlCol="0" anchor="ctr"/>
-          <a:lstStyle/>
-          <a:p>
-            <a:pPr indent="0" marL="0">
-              <a:buNone/>
-            </a:pPr>
-            <a:r>
-              <a:rPr lang="en-US" sz="900" dirty="0">
-                <a:solidFill>
-                  <a:srgbClr val="9CA3AF"/>
-                </a:solidFill>
-              </a:rPr>
-              <a:t>IDs refer to our Team Hub interview logs</a:t>
+              <a:t>Research</a:t>
             </a:r>
             <a:endParaRPr lang="en-US" sz="900" dirty="0"/>
           </a:p>

</xml_diff>